<commit_message>
fix: add visible AI prompt boxes to low-tech templates
Founders using the PPTX templates had no way to see the AI prompts
which were hidden in speaker notes. Added a visible prompt box to
every slide that has an AI prompt, with an orange header, pale
background, and clear instructions to copy and paste into ChatGPT
or Claude. Prompts remain in speaker notes as well.

Co-Authored-By: Claude Opus 4.6 (1M context) <noreply@anthropic.com>
</commit_message>
<xml_diff>
--- a/low-tech/deck-building.pptx
+++ b/low-tech/deck-building.pptx
@@ -4912,6 +4912,70 @@
           </a:p>
         </p:txBody>
       </p:sp>
+      <p:sp>
+        <p:nvSpPr>
+          <p:cNvPr id="4" name="TextBox 3"/>
+          <p:cNvSpPr txBox="1"/>
+          <p:nvPr/>
+        </p:nvSpPr>
+        <p:spPr>
+          <a:xfrm>
+            <a:off x="457200" y="5029200"/>
+            <a:ext cx="8229600" cy="1645920"/>
+          </a:xfrm>
+          <a:prstGeom prst="rect">
+            <a:avLst/>
+          </a:prstGeom>
+          <a:solidFill>
+            <a:srgbClr val="FFF7ED"/>
+          </a:solidFill>
+          <a:ln w="12700">
+            <a:solidFill>
+              <a:srgbClr val="EA580D"/>
+            </a:solidFill>
+          </a:ln>
+        </p:spPr>
+        <p:txBody>
+          <a:bodyPr wrap="square">
+            <a:spAutoFit/>
+          </a:bodyPr>
+          <a:lstStyle/>
+          <a:p>
+            <a:r>
+              <a:rPr sz="800" b="1">
+                <a:solidFill>
+                  <a:srgbClr val="EA580D"/>
+                </a:solidFill>
+              </a:rPr>
+              <a:t>AI COACH PROMPT</a:t>
+            </a:r>
+          </a:p>
+          <a:p>
+            <a:r>
+              <a:rPr sz="700">
+                <a:solidFill>
+                  <a:srgbClr val="64748B"/>
+                </a:solidFill>
+              </a:rPr>
+              <a:t>Copy the text below and paste it into ChatGPT, Claude, or any AI tool:</a:t>
+            </a:r>
+          </a:p>
+          <a:p>
+            <a:r>
+              <a:rPr sz="700" i="1">
+                <a:solidFill>
+                  <a:srgbClr val="0F172A"/>
+                </a:solidFill>
+              </a:rPr>
+              <a:t>I am building [describe your startup]. I am working on the The Vision slide of my pitch deck. Here is my current draft:
+Key Narrative: [paste yours]
+Proof Points: [paste yours]
+So What?: [paste yours]
+Help me sharpen this. Challenge weak claims, suggest stronger evidence, and rewrite the narrative to be more compelling. Keep it concise. Invest...</a:t>
+            </a:r>
+          </a:p>
+        </p:txBody>
+      </p:sp>
     </p:spTree>
   </p:cSld>
   <p:clrMapOvr>
@@ -5147,6 +5211,70 @@
           </a:p>
         </p:txBody>
       </p:sp>
+      <p:sp>
+        <p:nvSpPr>
+          <p:cNvPr id="4" name="TextBox 3"/>
+          <p:cNvSpPr txBox="1"/>
+          <p:nvPr/>
+        </p:nvSpPr>
+        <p:spPr>
+          <a:xfrm>
+            <a:off x="457200" y="5029200"/>
+            <a:ext cx="8229600" cy="1645920"/>
+          </a:xfrm>
+          <a:prstGeom prst="rect">
+            <a:avLst/>
+          </a:prstGeom>
+          <a:solidFill>
+            <a:srgbClr val="FFF7ED"/>
+          </a:solidFill>
+          <a:ln w="12700">
+            <a:solidFill>
+              <a:srgbClr val="EA580D"/>
+            </a:solidFill>
+          </a:ln>
+        </p:spPr>
+        <p:txBody>
+          <a:bodyPr wrap="square">
+            <a:spAutoFit/>
+          </a:bodyPr>
+          <a:lstStyle/>
+          <a:p>
+            <a:r>
+              <a:rPr sz="800" b="1">
+                <a:solidFill>
+                  <a:srgbClr val="EA580D"/>
+                </a:solidFill>
+              </a:rPr>
+              <a:t>AI COACH PROMPT</a:t>
+            </a:r>
+          </a:p>
+          <a:p>
+            <a:r>
+              <a:rPr sz="700">
+                <a:solidFill>
+                  <a:srgbClr val="64748B"/>
+                </a:solidFill>
+              </a:rPr>
+              <a:t>Copy the text below and paste it into ChatGPT, Claude, or any AI tool:</a:t>
+            </a:r>
+          </a:p>
+          <a:p>
+            <a:r>
+              <a:rPr sz="700" i="1">
+                <a:solidFill>
+                  <a:srgbClr val="0F172A"/>
+                </a:solidFill>
+              </a:rPr>
+              <a:t>I am building [describe your startup]. I am working on the The Ask slide of my pitch deck. Here is my current draft:
+Key Narrative: [paste yours]
+Proof Points: [paste yours]
+So What?: [paste yours]
+Help me sharpen this. Challenge weak claims, suggest stronger evidence, and rewrite the narrative to be more compelling. Keep it concise. Investors...</a:t>
+            </a:r>
+          </a:p>
+        </p:txBody>
+      </p:sp>
     </p:spTree>
   </p:cSld>
   <p:clrMapOvr>
@@ -5361,6 +5489,70 @@
           </a:p>
         </p:txBody>
       </p:sp>
+      <p:sp>
+        <p:nvSpPr>
+          <p:cNvPr id="4" name="TextBox 3"/>
+          <p:cNvSpPr txBox="1"/>
+          <p:nvPr/>
+        </p:nvSpPr>
+        <p:spPr>
+          <a:xfrm>
+            <a:off x="457200" y="5029200"/>
+            <a:ext cx="8229600" cy="1645920"/>
+          </a:xfrm>
+          <a:prstGeom prst="rect">
+            <a:avLst/>
+          </a:prstGeom>
+          <a:solidFill>
+            <a:srgbClr val="FFF7ED"/>
+          </a:solidFill>
+          <a:ln w="12700">
+            <a:solidFill>
+              <a:srgbClr val="EA580D"/>
+            </a:solidFill>
+          </a:ln>
+        </p:spPr>
+        <p:txBody>
+          <a:bodyPr wrap="square">
+            <a:spAutoFit/>
+          </a:bodyPr>
+          <a:lstStyle/>
+          <a:p>
+            <a:r>
+              <a:rPr sz="800" b="1">
+                <a:solidFill>
+                  <a:srgbClr val="EA580D"/>
+                </a:solidFill>
+              </a:rPr>
+              <a:t>AI COACH PROMPT</a:t>
+            </a:r>
+          </a:p>
+          <a:p>
+            <a:r>
+              <a:rPr sz="700">
+                <a:solidFill>
+                  <a:srgbClr val="64748B"/>
+                </a:solidFill>
+              </a:rPr>
+              <a:t>Copy the text below and paste it into ChatGPT, Claude, or any AI tool:</a:t>
+            </a:r>
+          </a:p>
+          <a:p>
+            <a:r>
+              <a:rPr sz="700" i="1">
+                <a:solidFill>
+                  <a:srgbClr val="0F172A"/>
+                </a:solidFill>
+              </a:rPr>
+              <a:t>I am building [describe your startup]. I am working on the deck versions slide of my pitch deck. Here is my current draft:
+Key Narrative: [paste yours]
+Proof Points: [paste yours]
+So What?: [paste yours]
+Help me sharpen this. Challenge weak claims, suggest stronger evidence, and rewrite the narrative to be more compelling. Keep it concise. Inv...</a:t>
+            </a:r>
+          </a:p>
+        </p:txBody>
+      </p:sp>
     </p:spTree>
   </p:cSld>
   <p:clrMapOvr>
@@ -5701,6 +5893,70 @@
           </a:p>
         </p:txBody>
       </p:sp>
+      <p:sp>
+        <p:nvSpPr>
+          <p:cNvPr id="4" name="TextBox 3"/>
+          <p:cNvSpPr txBox="1"/>
+          <p:nvPr/>
+        </p:nvSpPr>
+        <p:spPr>
+          <a:xfrm>
+            <a:off x="457200" y="5029200"/>
+            <a:ext cx="8229600" cy="1645920"/>
+          </a:xfrm>
+          <a:prstGeom prst="rect">
+            <a:avLst/>
+          </a:prstGeom>
+          <a:solidFill>
+            <a:srgbClr val="FFF7ED"/>
+          </a:solidFill>
+          <a:ln w="12700">
+            <a:solidFill>
+              <a:srgbClr val="EA580D"/>
+            </a:solidFill>
+          </a:ln>
+        </p:spPr>
+        <p:txBody>
+          <a:bodyPr wrap="square">
+            <a:spAutoFit/>
+          </a:bodyPr>
+          <a:lstStyle/>
+          <a:p>
+            <a:r>
+              <a:rPr sz="800" b="1">
+                <a:solidFill>
+                  <a:srgbClr val="EA580D"/>
+                </a:solidFill>
+              </a:rPr>
+              <a:t>AI COACH PROMPT</a:t>
+            </a:r>
+          </a:p>
+          <a:p>
+            <a:r>
+              <a:rPr sz="700">
+                <a:solidFill>
+                  <a:srgbClr val="64748B"/>
+                </a:solidFill>
+              </a:rPr>
+              <a:t>Copy the text below and paste it into ChatGPT, Claude, or any AI tool:</a:t>
+            </a:r>
+          </a:p>
+          <a:p>
+            <a:r>
+              <a:rPr sz="700" i="1">
+                <a:solidFill>
+                  <a:srgbClr val="0F172A"/>
+                </a:solidFill>
+              </a:rPr>
+              <a:t>I am building [describe your startup]. I am working on the forwardable email slide of my pitch deck. Here is my current draft:
+Key Narrative: [paste yours]
+Proof Points: [paste yours]
+So What?: [paste yours]
+Help me sharpen this. Challenge weak claims, suggest stronger evidence, and rewrite the narrative to be more compelling. Keep it concise....</a:t>
+            </a:r>
+          </a:p>
+        </p:txBody>
+      </p:sp>
     </p:spTree>
   </p:cSld>
   <p:clrMapOvr>
@@ -5936,6 +6192,70 @@
           </a:p>
         </p:txBody>
       </p:sp>
+      <p:sp>
+        <p:nvSpPr>
+          <p:cNvPr id="4" name="TextBox 3"/>
+          <p:cNvSpPr txBox="1"/>
+          <p:nvPr/>
+        </p:nvSpPr>
+        <p:spPr>
+          <a:xfrm>
+            <a:off x="457200" y="5029200"/>
+            <a:ext cx="8229600" cy="1645920"/>
+          </a:xfrm>
+          <a:prstGeom prst="rect">
+            <a:avLst/>
+          </a:prstGeom>
+          <a:solidFill>
+            <a:srgbClr val="FFF7ED"/>
+          </a:solidFill>
+          <a:ln w="12700">
+            <a:solidFill>
+              <a:srgbClr val="EA580D"/>
+            </a:solidFill>
+          </a:ln>
+        </p:spPr>
+        <p:txBody>
+          <a:bodyPr wrap="square">
+            <a:spAutoFit/>
+          </a:bodyPr>
+          <a:lstStyle/>
+          <a:p>
+            <a:r>
+              <a:rPr sz="800" b="1">
+                <a:solidFill>
+                  <a:srgbClr val="EA580D"/>
+                </a:solidFill>
+              </a:rPr>
+              <a:t>AI COACH PROMPT</a:t>
+            </a:r>
+          </a:p>
+          <a:p>
+            <a:r>
+              <a:rPr sz="700">
+                <a:solidFill>
+                  <a:srgbClr val="64748B"/>
+                </a:solidFill>
+              </a:rPr>
+              <a:t>Copy the text below and paste it into ChatGPT, Claude, or any AI tool:</a:t>
+            </a:r>
+          </a:p>
+          <a:p>
+            <a:r>
+              <a:rPr sz="700" i="1">
+                <a:solidFill>
+                  <a:srgbClr val="0F172A"/>
+                </a:solidFill>
+              </a:rPr>
+              <a:t>I am building [describe your startup]. I am working on the The Hook slide of my pitch deck. Here is my current draft:
+Key Narrative: [paste yours]
+Proof Points: [paste yours]
+So What?: [paste yours]
+Help me sharpen this. Challenge weak claims, suggest stronger evidence, and rewrite the narrative to be more compelling. Keep it concise. Investor...</a:t>
+            </a:r>
+          </a:p>
+        </p:txBody>
+      </p:sp>
     </p:spTree>
   </p:cSld>
   <p:clrMapOvr>
@@ -6171,6 +6491,70 @@
           </a:p>
         </p:txBody>
       </p:sp>
+      <p:sp>
+        <p:nvSpPr>
+          <p:cNvPr id="4" name="TextBox 3"/>
+          <p:cNvSpPr txBox="1"/>
+          <p:nvPr/>
+        </p:nvSpPr>
+        <p:spPr>
+          <a:xfrm>
+            <a:off x="457200" y="5029200"/>
+            <a:ext cx="8229600" cy="1645920"/>
+          </a:xfrm>
+          <a:prstGeom prst="rect">
+            <a:avLst/>
+          </a:prstGeom>
+          <a:solidFill>
+            <a:srgbClr val="FFF7ED"/>
+          </a:solidFill>
+          <a:ln w="12700">
+            <a:solidFill>
+              <a:srgbClr val="EA580D"/>
+            </a:solidFill>
+          </a:ln>
+        </p:spPr>
+        <p:txBody>
+          <a:bodyPr wrap="square">
+            <a:spAutoFit/>
+          </a:bodyPr>
+          <a:lstStyle/>
+          <a:p>
+            <a:r>
+              <a:rPr sz="800" b="1">
+                <a:solidFill>
+                  <a:srgbClr val="EA580D"/>
+                </a:solidFill>
+              </a:rPr>
+              <a:t>AI COACH PROMPT</a:t>
+            </a:r>
+          </a:p>
+          <a:p>
+            <a:r>
+              <a:rPr sz="700">
+                <a:solidFill>
+                  <a:srgbClr val="64748B"/>
+                </a:solidFill>
+              </a:rPr>
+              <a:t>Copy the text below and paste it into ChatGPT, Claude, or any AI tool:</a:t>
+            </a:r>
+          </a:p>
+          <a:p>
+            <a:r>
+              <a:rPr sz="700" i="1">
+                <a:solidFill>
+                  <a:srgbClr val="0F172A"/>
+                </a:solidFill>
+              </a:rPr>
+              <a:t>I am building [describe your startup]. I am working on the The Problem slide of my pitch deck. Here is my current draft:
+Key Narrative: [paste yours]
+Proof Points: [paste yours]
+So What?: [paste yours]
+Help me sharpen this. Challenge weak claims, suggest stronger evidence, and rewrite the narrative to be more compelling. Keep it concise. Inves...</a:t>
+            </a:r>
+          </a:p>
+        </p:txBody>
+      </p:sp>
     </p:spTree>
   </p:cSld>
   <p:clrMapOvr>
@@ -6406,6 +6790,70 @@
           </a:p>
         </p:txBody>
       </p:sp>
+      <p:sp>
+        <p:nvSpPr>
+          <p:cNvPr id="4" name="TextBox 3"/>
+          <p:cNvSpPr txBox="1"/>
+          <p:nvPr/>
+        </p:nvSpPr>
+        <p:spPr>
+          <a:xfrm>
+            <a:off x="457200" y="5029200"/>
+            <a:ext cx="8229600" cy="1645920"/>
+          </a:xfrm>
+          <a:prstGeom prst="rect">
+            <a:avLst/>
+          </a:prstGeom>
+          <a:solidFill>
+            <a:srgbClr val="FFF7ED"/>
+          </a:solidFill>
+          <a:ln w="12700">
+            <a:solidFill>
+              <a:srgbClr val="EA580D"/>
+            </a:solidFill>
+          </a:ln>
+        </p:spPr>
+        <p:txBody>
+          <a:bodyPr wrap="square">
+            <a:spAutoFit/>
+          </a:bodyPr>
+          <a:lstStyle/>
+          <a:p>
+            <a:r>
+              <a:rPr sz="800" b="1">
+                <a:solidFill>
+                  <a:srgbClr val="EA580D"/>
+                </a:solidFill>
+              </a:rPr>
+              <a:t>AI COACH PROMPT</a:t>
+            </a:r>
+          </a:p>
+          <a:p>
+            <a:r>
+              <a:rPr sz="700">
+                <a:solidFill>
+                  <a:srgbClr val="64748B"/>
+                </a:solidFill>
+              </a:rPr>
+              <a:t>Copy the text below and paste it into ChatGPT, Claude, or any AI tool:</a:t>
+            </a:r>
+          </a:p>
+          <a:p>
+            <a:r>
+              <a:rPr sz="700" i="1">
+                <a:solidFill>
+                  <a:srgbClr val="0F172A"/>
+                </a:solidFill>
+              </a:rPr>
+              <a:t>I am building [describe your startup]. I am working on the The Solution slide of my pitch deck. Here is my current draft:
+Key Narrative: [paste yours]
+Proof Points: [paste yours]
+So What?: [paste yours]
+Help me sharpen this. Challenge weak claims, suggest stronger evidence, and rewrite the narrative to be more compelling. Keep it concise. Inve...</a:t>
+            </a:r>
+          </a:p>
+        </p:txBody>
+      </p:sp>
     </p:spTree>
   </p:cSld>
   <p:clrMapOvr>
@@ -6641,6 +7089,70 @@
           </a:p>
         </p:txBody>
       </p:sp>
+      <p:sp>
+        <p:nvSpPr>
+          <p:cNvPr id="4" name="TextBox 3"/>
+          <p:cNvSpPr txBox="1"/>
+          <p:nvPr/>
+        </p:nvSpPr>
+        <p:spPr>
+          <a:xfrm>
+            <a:off x="457200" y="5029200"/>
+            <a:ext cx="8229600" cy="1645920"/>
+          </a:xfrm>
+          <a:prstGeom prst="rect">
+            <a:avLst/>
+          </a:prstGeom>
+          <a:solidFill>
+            <a:srgbClr val="FFF7ED"/>
+          </a:solidFill>
+          <a:ln w="12700">
+            <a:solidFill>
+              <a:srgbClr val="EA580D"/>
+            </a:solidFill>
+          </a:ln>
+        </p:spPr>
+        <p:txBody>
+          <a:bodyPr wrap="square">
+            <a:spAutoFit/>
+          </a:bodyPr>
+          <a:lstStyle/>
+          <a:p>
+            <a:r>
+              <a:rPr sz="800" b="1">
+                <a:solidFill>
+                  <a:srgbClr val="EA580D"/>
+                </a:solidFill>
+              </a:rPr>
+              <a:t>AI COACH PROMPT</a:t>
+            </a:r>
+          </a:p>
+          <a:p>
+            <a:r>
+              <a:rPr sz="700">
+                <a:solidFill>
+                  <a:srgbClr val="64748B"/>
+                </a:solidFill>
+              </a:rPr>
+              <a:t>Copy the text below and paste it into ChatGPT, Claude, or any AI tool:</a:t>
+            </a:r>
+          </a:p>
+          <a:p>
+            <a:r>
+              <a:rPr sz="700" i="1">
+                <a:solidFill>
+                  <a:srgbClr val="0F172A"/>
+                </a:solidFill>
+              </a:rPr>
+              <a:t>I am building [describe your startup]. I am working on the The Market slide of my pitch deck. Here is my current draft:
+Key Narrative: [paste yours]
+Proof Points: [paste yours]
+So What?: [paste yours]
+Help me sharpen this. Challenge weak claims, suggest stronger evidence, and rewrite the narrative to be more compelling. Keep it concise. Invest...</a:t>
+            </a:r>
+          </a:p>
+        </p:txBody>
+      </p:sp>
     </p:spTree>
   </p:cSld>
   <p:clrMapOvr>
@@ -6876,6 +7388,70 @@
           </a:p>
         </p:txBody>
       </p:sp>
+      <p:sp>
+        <p:nvSpPr>
+          <p:cNvPr id="4" name="TextBox 3"/>
+          <p:cNvSpPr txBox="1"/>
+          <p:nvPr/>
+        </p:nvSpPr>
+        <p:spPr>
+          <a:xfrm>
+            <a:off x="457200" y="5029200"/>
+            <a:ext cx="8229600" cy="1645920"/>
+          </a:xfrm>
+          <a:prstGeom prst="rect">
+            <a:avLst/>
+          </a:prstGeom>
+          <a:solidFill>
+            <a:srgbClr val="FFF7ED"/>
+          </a:solidFill>
+          <a:ln w="12700">
+            <a:solidFill>
+              <a:srgbClr val="EA580D"/>
+            </a:solidFill>
+          </a:ln>
+        </p:spPr>
+        <p:txBody>
+          <a:bodyPr wrap="square">
+            <a:spAutoFit/>
+          </a:bodyPr>
+          <a:lstStyle/>
+          <a:p>
+            <a:r>
+              <a:rPr sz="800" b="1">
+                <a:solidFill>
+                  <a:srgbClr val="EA580D"/>
+                </a:solidFill>
+              </a:rPr>
+              <a:t>AI COACH PROMPT</a:t>
+            </a:r>
+          </a:p>
+          <a:p>
+            <a:r>
+              <a:rPr sz="700">
+                <a:solidFill>
+                  <a:srgbClr val="64748B"/>
+                </a:solidFill>
+              </a:rPr>
+              <a:t>Copy the text below and paste it into ChatGPT, Claude, or any AI tool:</a:t>
+            </a:r>
+          </a:p>
+          <a:p>
+            <a:r>
+              <a:rPr sz="700" i="1">
+                <a:solidFill>
+                  <a:srgbClr val="0F172A"/>
+                </a:solidFill>
+              </a:rPr>
+              <a:t>I am building [describe your startup]. I am working on the The Product slide of my pitch deck. Here is my current draft:
+Key Narrative: [paste yours]
+Proof Points: [paste yours]
+So What?: [paste yours]
+Help me sharpen this. Challenge weak claims, suggest stronger evidence, and rewrite the narrative to be more compelling. Keep it concise. Inves...</a:t>
+            </a:r>
+          </a:p>
+        </p:txBody>
+      </p:sp>
     </p:spTree>
   </p:cSld>
   <p:clrMapOvr>
@@ -7111,6 +7687,70 @@
           </a:p>
         </p:txBody>
       </p:sp>
+      <p:sp>
+        <p:nvSpPr>
+          <p:cNvPr id="4" name="TextBox 3"/>
+          <p:cNvSpPr txBox="1"/>
+          <p:nvPr/>
+        </p:nvSpPr>
+        <p:spPr>
+          <a:xfrm>
+            <a:off x="457200" y="5029200"/>
+            <a:ext cx="8229600" cy="1645920"/>
+          </a:xfrm>
+          <a:prstGeom prst="rect">
+            <a:avLst/>
+          </a:prstGeom>
+          <a:solidFill>
+            <a:srgbClr val="FFF7ED"/>
+          </a:solidFill>
+          <a:ln w="12700">
+            <a:solidFill>
+              <a:srgbClr val="EA580D"/>
+            </a:solidFill>
+          </a:ln>
+        </p:spPr>
+        <p:txBody>
+          <a:bodyPr wrap="square">
+            <a:spAutoFit/>
+          </a:bodyPr>
+          <a:lstStyle/>
+          <a:p>
+            <a:r>
+              <a:rPr sz="800" b="1">
+                <a:solidFill>
+                  <a:srgbClr val="EA580D"/>
+                </a:solidFill>
+              </a:rPr>
+              <a:t>AI COACH PROMPT</a:t>
+            </a:r>
+          </a:p>
+          <a:p>
+            <a:r>
+              <a:rPr sz="700">
+                <a:solidFill>
+                  <a:srgbClr val="64748B"/>
+                </a:solidFill>
+              </a:rPr>
+              <a:t>Copy the text below and paste it into ChatGPT, Claude, or any AI tool:</a:t>
+            </a:r>
+          </a:p>
+          <a:p>
+            <a:r>
+              <a:rPr sz="700" i="1">
+                <a:solidFill>
+                  <a:srgbClr val="0F172A"/>
+                </a:solidFill>
+              </a:rPr>
+              <a:t>I am building [describe your startup]. I am working on the Business Model slide of my pitch deck. Here is my current draft:
+Key Narrative: [paste yours]
+Proof Points: [paste yours]
+So What?: [paste yours]
+Help me sharpen this. Challenge weak claims, suggest stronger evidence, and rewrite the narrative to be more compelling. Keep it concise. In...</a:t>
+            </a:r>
+          </a:p>
+        </p:txBody>
+      </p:sp>
     </p:spTree>
   </p:cSld>
   <p:clrMapOvr>
@@ -7346,6 +7986,70 @@
           </a:p>
         </p:txBody>
       </p:sp>
+      <p:sp>
+        <p:nvSpPr>
+          <p:cNvPr id="4" name="TextBox 3"/>
+          <p:cNvSpPr txBox="1"/>
+          <p:nvPr/>
+        </p:nvSpPr>
+        <p:spPr>
+          <a:xfrm>
+            <a:off x="457200" y="5029200"/>
+            <a:ext cx="8229600" cy="1645920"/>
+          </a:xfrm>
+          <a:prstGeom prst="rect">
+            <a:avLst/>
+          </a:prstGeom>
+          <a:solidFill>
+            <a:srgbClr val="FFF7ED"/>
+          </a:solidFill>
+          <a:ln w="12700">
+            <a:solidFill>
+              <a:srgbClr val="EA580D"/>
+            </a:solidFill>
+          </a:ln>
+        </p:spPr>
+        <p:txBody>
+          <a:bodyPr wrap="square">
+            <a:spAutoFit/>
+          </a:bodyPr>
+          <a:lstStyle/>
+          <a:p>
+            <a:r>
+              <a:rPr sz="800" b="1">
+                <a:solidFill>
+                  <a:srgbClr val="EA580D"/>
+                </a:solidFill>
+              </a:rPr>
+              <a:t>AI COACH PROMPT</a:t>
+            </a:r>
+          </a:p>
+          <a:p>
+            <a:r>
+              <a:rPr sz="700">
+                <a:solidFill>
+                  <a:srgbClr val="64748B"/>
+                </a:solidFill>
+              </a:rPr>
+              <a:t>Copy the text below and paste it into ChatGPT, Claude, or any AI tool:</a:t>
+            </a:r>
+          </a:p>
+          <a:p>
+            <a:r>
+              <a:rPr sz="700" i="1">
+                <a:solidFill>
+                  <a:srgbClr val="0F172A"/>
+                </a:solidFill>
+              </a:rPr>
+              <a:t>I am building [describe your startup]. I am working on the Traction slide of my pitch deck. Here is my current draft:
+Key Narrative: [paste yours]
+Proof Points: [paste yours]
+So What?: [paste yours]
+Help me sharpen this. Challenge weak claims, suggest stronger evidence, and rewrite the narrative to be more compelling. Keep it concise. Investor...</a:t>
+            </a:r>
+          </a:p>
+        </p:txBody>
+      </p:sp>
     </p:spTree>
   </p:cSld>
   <p:clrMapOvr>
@@ -7577,6 +8281,70 @@
                 <a:latin typeface="Calibri"/>
               </a:rPr>
               <a:t>________________________________________</a:t>
+            </a:r>
+          </a:p>
+        </p:txBody>
+      </p:sp>
+      <p:sp>
+        <p:nvSpPr>
+          <p:cNvPr id="4" name="TextBox 3"/>
+          <p:cNvSpPr txBox="1"/>
+          <p:nvPr/>
+        </p:nvSpPr>
+        <p:spPr>
+          <a:xfrm>
+            <a:off x="457200" y="5029200"/>
+            <a:ext cx="8229600" cy="1645920"/>
+          </a:xfrm>
+          <a:prstGeom prst="rect">
+            <a:avLst/>
+          </a:prstGeom>
+          <a:solidFill>
+            <a:srgbClr val="FFF7ED"/>
+          </a:solidFill>
+          <a:ln w="12700">
+            <a:solidFill>
+              <a:srgbClr val="EA580D"/>
+            </a:solidFill>
+          </a:ln>
+        </p:spPr>
+        <p:txBody>
+          <a:bodyPr wrap="square">
+            <a:spAutoFit/>
+          </a:bodyPr>
+          <a:lstStyle/>
+          <a:p>
+            <a:r>
+              <a:rPr sz="800" b="1">
+                <a:solidFill>
+                  <a:srgbClr val="EA580D"/>
+                </a:solidFill>
+              </a:rPr>
+              <a:t>AI COACH PROMPT</a:t>
+            </a:r>
+          </a:p>
+          <a:p>
+            <a:r>
+              <a:rPr sz="700">
+                <a:solidFill>
+                  <a:srgbClr val="64748B"/>
+                </a:solidFill>
+              </a:rPr>
+              <a:t>Copy the text below and paste it into ChatGPT, Claude, or any AI tool:</a:t>
+            </a:r>
+          </a:p>
+          <a:p>
+            <a:r>
+              <a:rPr sz="700" i="1">
+                <a:solidFill>
+                  <a:srgbClr val="0F172A"/>
+                </a:solidFill>
+              </a:rPr>
+              <a:t>I am building [describe your startup]. I am working on the The Team slide of my pitch deck. Here is my current draft:
+Key Narrative: [paste yours]
+Proof Points: [paste yours]
+So What?: [paste yours]
+Help me sharpen this. Challenge weak claims, suggest stronger evidence, and rewrite the narrative to be more compelling. Keep it concise. Investor...</a:t>
             </a:r>
           </a:p>
         </p:txBody>

</xml_diff>

<commit_message>
feat: add standalone AI prompts file for low-tech track
Replaces cluttered per-slide prompt boxes with a single AI-PROMPTS.md
file. Founders open it, copy the prompt for their exercise, paste it
into ChatGPT or Claude, and start coaching immediately. Each prompt
sets up a full conversational coaching session with role, structure,
and a clear starting question.

PPTX slide 1 of each template now points to AI-PROMPTS.md. README
and SETUP.md updated to describe the new workflow.

Co-Authored-By: Claude Opus 4.6 (1M context) <noreply@anthropic.com>
</commit_message>
<xml_diff>
--- a/low-tech/deck-building.pptx
+++ b/low-tech/deck-building.pptx
@@ -4677,6 +4677,39 @@
           </a:p>
         </p:txBody>
       </p:sp>
+      <p:sp>
+        <p:nvSpPr>
+          <p:cNvPr id="3" name="TextBox 2"/>
+          <p:cNvSpPr txBox="1"/>
+          <p:nvPr/>
+        </p:nvSpPr>
+        <p:spPr>
+          <a:xfrm>
+            <a:off x="457200" y="5760720"/>
+            <a:ext cx="8229600" cy="457200"/>
+          </a:xfrm>
+          <a:prstGeom prst="rect">
+            <a:avLst/>
+          </a:prstGeom>
+          <a:noFill/>
+        </p:spPr>
+        <p:txBody>
+          <a:bodyPr wrap="square">
+            <a:spAutoFit/>
+          </a:bodyPr>
+          <a:lstStyle/>
+          <a:p>
+            <a:r>
+              <a:rPr sz="900" b="0">
+                <a:solidFill>
+                  <a:srgbClr val="EA580D"/>
+                </a:solidFill>
+              </a:rPr>
+              <a:t>Want AI coaching? Open AI-PROMPTS.md, copy the prompt for this exercise, and paste it into ChatGPT or Claude.</a:t>
+            </a:r>
+          </a:p>
+        </p:txBody>
+      </p:sp>
     </p:spTree>
   </p:cSld>
   <p:clrMapOvr>
@@ -4912,70 +4945,6 @@
           </a:p>
         </p:txBody>
       </p:sp>
-      <p:sp>
-        <p:nvSpPr>
-          <p:cNvPr id="4" name="TextBox 3"/>
-          <p:cNvSpPr txBox="1"/>
-          <p:nvPr/>
-        </p:nvSpPr>
-        <p:spPr>
-          <a:xfrm>
-            <a:off x="457200" y="5029200"/>
-            <a:ext cx="8229600" cy="1645920"/>
-          </a:xfrm>
-          <a:prstGeom prst="rect">
-            <a:avLst/>
-          </a:prstGeom>
-          <a:solidFill>
-            <a:srgbClr val="FFF7ED"/>
-          </a:solidFill>
-          <a:ln w="12700">
-            <a:solidFill>
-              <a:srgbClr val="EA580D"/>
-            </a:solidFill>
-          </a:ln>
-        </p:spPr>
-        <p:txBody>
-          <a:bodyPr wrap="square">
-            <a:spAutoFit/>
-          </a:bodyPr>
-          <a:lstStyle/>
-          <a:p>
-            <a:r>
-              <a:rPr sz="800" b="1">
-                <a:solidFill>
-                  <a:srgbClr val="EA580D"/>
-                </a:solidFill>
-              </a:rPr>
-              <a:t>AI COACH PROMPT</a:t>
-            </a:r>
-          </a:p>
-          <a:p>
-            <a:r>
-              <a:rPr sz="700">
-                <a:solidFill>
-                  <a:srgbClr val="64748B"/>
-                </a:solidFill>
-              </a:rPr>
-              <a:t>Copy the text below and paste it into ChatGPT, Claude, or any AI tool:</a:t>
-            </a:r>
-          </a:p>
-          <a:p>
-            <a:r>
-              <a:rPr sz="700" i="1">
-                <a:solidFill>
-                  <a:srgbClr val="0F172A"/>
-                </a:solidFill>
-              </a:rPr>
-              <a:t>I am building [describe your startup]. I am working on the The Vision slide of my pitch deck. Here is my current draft:
-Key Narrative: [paste yours]
-Proof Points: [paste yours]
-So What?: [paste yours]
-Help me sharpen this. Challenge weak claims, suggest stronger evidence, and rewrite the narrative to be more compelling. Keep it concise. Invest...</a:t>
-            </a:r>
-          </a:p>
-        </p:txBody>
-      </p:sp>
     </p:spTree>
   </p:cSld>
   <p:clrMapOvr>
@@ -5211,70 +5180,6 @@
           </a:p>
         </p:txBody>
       </p:sp>
-      <p:sp>
-        <p:nvSpPr>
-          <p:cNvPr id="4" name="TextBox 3"/>
-          <p:cNvSpPr txBox="1"/>
-          <p:nvPr/>
-        </p:nvSpPr>
-        <p:spPr>
-          <a:xfrm>
-            <a:off x="457200" y="5029200"/>
-            <a:ext cx="8229600" cy="1645920"/>
-          </a:xfrm>
-          <a:prstGeom prst="rect">
-            <a:avLst/>
-          </a:prstGeom>
-          <a:solidFill>
-            <a:srgbClr val="FFF7ED"/>
-          </a:solidFill>
-          <a:ln w="12700">
-            <a:solidFill>
-              <a:srgbClr val="EA580D"/>
-            </a:solidFill>
-          </a:ln>
-        </p:spPr>
-        <p:txBody>
-          <a:bodyPr wrap="square">
-            <a:spAutoFit/>
-          </a:bodyPr>
-          <a:lstStyle/>
-          <a:p>
-            <a:r>
-              <a:rPr sz="800" b="1">
-                <a:solidFill>
-                  <a:srgbClr val="EA580D"/>
-                </a:solidFill>
-              </a:rPr>
-              <a:t>AI COACH PROMPT</a:t>
-            </a:r>
-          </a:p>
-          <a:p>
-            <a:r>
-              <a:rPr sz="700">
-                <a:solidFill>
-                  <a:srgbClr val="64748B"/>
-                </a:solidFill>
-              </a:rPr>
-              <a:t>Copy the text below and paste it into ChatGPT, Claude, or any AI tool:</a:t>
-            </a:r>
-          </a:p>
-          <a:p>
-            <a:r>
-              <a:rPr sz="700" i="1">
-                <a:solidFill>
-                  <a:srgbClr val="0F172A"/>
-                </a:solidFill>
-              </a:rPr>
-              <a:t>I am building [describe your startup]. I am working on the The Ask slide of my pitch deck. Here is my current draft:
-Key Narrative: [paste yours]
-Proof Points: [paste yours]
-So What?: [paste yours]
-Help me sharpen this. Challenge weak claims, suggest stronger evidence, and rewrite the narrative to be more compelling. Keep it concise. Investors...</a:t>
-            </a:r>
-          </a:p>
-        </p:txBody>
-      </p:sp>
     </p:spTree>
   </p:cSld>
   <p:clrMapOvr>
@@ -5489,70 +5394,6 @@
           </a:p>
         </p:txBody>
       </p:sp>
-      <p:sp>
-        <p:nvSpPr>
-          <p:cNvPr id="4" name="TextBox 3"/>
-          <p:cNvSpPr txBox="1"/>
-          <p:nvPr/>
-        </p:nvSpPr>
-        <p:spPr>
-          <a:xfrm>
-            <a:off x="457200" y="5029200"/>
-            <a:ext cx="8229600" cy="1645920"/>
-          </a:xfrm>
-          <a:prstGeom prst="rect">
-            <a:avLst/>
-          </a:prstGeom>
-          <a:solidFill>
-            <a:srgbClr val="FFF7ED"/>
-          </a:solidFill>
-          <a:ln w="12700">
-            <a:solidFill>
-              <a:srgbClr val="EA580D"/>
-            </a:solidFill>
-          </a:ln>
-        </p:spPr>
-        <p:txBody>
-          <a:bodyPr wrap="square">
-            <a:spAutoFit/>
-          </a:bodyPr>
-          <a:lstStyle/>
-          <a:p>
-            <a:r>
-              <a:rPr sz="800" b="1">
-                <a:solidFill>
-                  <a:srgbClr val="EA580D"/>
-                </a:solidFill>
-              </a:rPr>
-              <a:t>AI COACH PROMPT</a:t>
-            </a:r>
-          </a:p>
-          <a:p>
-            <a:r>
-              <a:rPr sz="700">
-                <a:solidFill>
-                  <a:srgbClr val="64748B"/>
-                </a:solidFill>
-              </a:rPr>
-              <a:t>Copy the text below and paste it into ChatGPT, Claude, or any AI tool:</a:t>
-            </a:r>
-          </a:p>
-          <a:p>
-            <a:r>
-              <a:rPr sz="700" i="1">
-                <a:solidFill>
-                  <a:srgbClr val="0F172A"/>
-                </a:solidFill>
-              </a:rPr>
-              <a:t>I am building [describe your startup]. I am working on the deck versions slide of my pitch deck. Here is my current draft:
-Key Narrative: [paste yours]
-Proof Points: [paste yours]
-So What?: [paste yours]
-Help me sharpen this. Challenge weak claims, suggest stronger evidence, and rewrite the narrative to be more compelling. Keep it concise. Inv...</a:t>
-            </a:r>
-          </a:p>
-        </p:txBody>
-      </p:sp>
     </p:spTree>
   </p:cSld>
   <p:clrMapOvr>
@@ -5893,70 +5734,6 @@
           </a:p>
         </p:txBody>
       </p:sp>
-      <p:sp>
-        <p:nvSpPr>
-          <p:cNvPr id="4" name="TextBox 3"/>
-          <p:cNvSpPr txBox="1"/>
-          <p:nvPr/>
-        </p:nvSpPr>
-        <p:spPr>
-          <a:xfrm>
-            <a:off x="457200" y="5029200"/>
-            <a:ext cx="8229600" cy="1645920"/>
-          </a:xfrm>
-          <a:prstGeom prst="rect">
-            <a:avLst/>
-          </a:prstGeom>
-          <a:solidFill>
-            <a:srgbClr val="FFF7ED"/>
-          </a:solidFill>
-          <a:ln w="12700">
-            <a:solidFill>
-              <a:srgbClr val="EA580D"/>
-            </a:solidFill>
-          </a:ln>
-        </p:spPr>
-        <p:txBody>
-          <a:bodyPr wrap="square">
-            <a:spAutoFit/>
-          </a:bodyPr>
-          <a:lstStyle/>
-          <a:p>
-            <a:r>
-              <a:rPr sz="800" b="1">
-                <a:solidFill>
-                  <a:srgbClr val="EA580D"/>
-                </a:solidFill>
-              </a:rPr>
-              <a:t>AI COACH PROMPT</a:t>
-            </a:r>
-          </a:p>
-          <a:p>
-            <a:r>
-              <a:rPr sz="700">
-                <a:solidFill>
-                  <a:srgbClr val="64748B"/>
-                </a:solidFill>
-              </a:rPr>
-              <a:t>Copy the text below and paste it into ChatGPT, Claude, or any AI tool:</a:t>
-            </a:r>
-          </a:p>
-          <a:p>
-            <a:r>
-              <a:rPr sz="700" i="1">
-                <a:solidFill>
-                  <a:srgbClr val="0F172A"/>
-                </a:solidFill>
-              </a:rPr>
-              <a:t>I am building [describe your startup]. I am working on the forwardable email slide of my pitch deck. Here is my current draft:
-Key Narrative: [paste yours]
-Proof Points: [paste yours]
-So What?: [paste yours]
-Help me sharpen this. Challenge weak claims, suggest stronger evidence, and rewrite the narrative to be more compelling. Keep it concise....</a:t>
-            </a:r>
-          </a:p>
-        </p:txBody>
-      </p:sp>
     </p:spTree>
   </p:cSld>
   <p:clrMapOvr>
@@ -6192,70 +5969,6 @@
           </a:p>
         </p:txBody>
       </p:sp>
-      <p:sp>
-        <p:nvSpPr>
-          <p:cNvPr id="4" name="TextBox 3"/>
-          <p:cNvSpPr txBox="1"/>
-          <p:nvPr/>
-        </p:nvSpPr>
-        <p:spPr>
-          <a:xfrm>
-            <a:off x="457200" y="5029200"/>
-            <a:ext cx="8229600" cy="1645920"/>
-          </a:xfrm>
-          <a:prstGeom prst="rect">
-            <a:avLst/>
-          </a:prstGeom>
-          <a:solidFill>
-            <a:srgbClr val="FFF7ED"/>
-          </a:solidFill>
-          <a:ln w="12700">
-            <a:solidFill>
-              <a:srgbClr val="EA580D"/>
-            </a:solidFill>
-          </a:ln>
-        </p:spPr>
-        <p:txBody>
-          <a:bodyPr wrap="square">
-            <a:spAutoFit/>
-          </a:bodyPr>
-          <a:lstStyle/>
-          <a:p>
-            <a:r>
-              <a:rPr sz="800" b="1">
-                <a:solidFill>
-                  <a:srgbClr val="EA580D"/>
-                </a:solidFill>
-              </a:rPr>
-              <a:t>AI COACH PROMPT</a:t>
-            </a:r>
-          </a:p>
-          <a:p>
-            <a:r>
-              <a:rPr sz="700">
-                <a:solidFill>
-                  <a:srgbClr val="64748B"/>
-                </a:solidFill>
-              </a:rPr>
-              <a:t>Copy the text below and paste it into ChatGPT, Claude, or any AI tool:</a:t>
-            </a:r>
-          </a:p>
-          <a:p>
-            <a:r>
-              <a:rPr sz="700" i="1">
-                <a:solidFill>
-                  <a:srgbClr val="0F172A"/>
-                </a:solidFill>
-              </a:rPr>
-              <a:t>I am building [describe your startup]. I am working on the The Hook slide of my pitch deck. Here is my current draft:
-Key Narrative: [paste yours]
-Proof Points: [paste yours]
-So What?: [paste yours]
-Help me sharpen this. Challenge weak claims, suggest stronger evidence, and rewrite the narrative to be more compelling. Keep it concise. Investor...</a:t>
-            </a:r>
-          </a:p>
-        </p:txBody>
-      </p:sp>
     </p:spTree>
   </p:cSld>
   <p:clrMapOvr>
@@ -6491,70 +6204,6 @@
           </a:p>
         </p:txBody>
       </p:sp>
-      <p:sp>
-        <p:nvSpPr>
-          <p:cNvPr id="4" name="TextBox 3"/>
-          <p:cNvSpPr txBox="1"/>
-          <p:nvPr/>
-        </p:nvSpPr>
-        <p:spPr>
-          <a:xfrm>
-            <a:off x="457200" y="5029200"/>
-            <a:ext cx="8229600" cy="1645920"/>
-          </a:xfrm>
-          <a:prstGeom prst="rect">
-            <a:avLst/>
-          </a:prstGeom>
-          <a:solidFill>
-            <a:srgbClr val="FFF7ED"/>
-          </a:solidFill>
-          <a:ln w="12700">
-            <a:solidFill>
-              <a:srgbClr val="EA580D"/>
-            </a:solidFill>
-          </a:ln>
-        </p:spPr>
-        <p:txBody>
-          <a:bodyPr wrap="square">
-            <a:spAutoFit/>
-          </a:bodyPr>
-          <a:lstStyle/>
-          <a:p>
-            <a:r>
-              <a:rPr sz="800" b="1">
-                <a:solidFill>
-                  <a:srgbClr val="EA580D"/>
-                </a:solidFill>
-              </a:rPr>
-              <a:t>AI COACH PROMPT</a:t>
-            </a:r>
-          </a:p>
-          <a:p>
-            <a:r>
-              <a:rPr sz="700">
-                <a:solidFill>
-                  <a:srgbClr val="64748B"/>
-                </a:solidFill>
-              </a:rPr>
-              <a:t>Copy the text below and paste it into ChatGPT, Claude, or any AI tool:</a:t>
-            </a:r>
-          </a:p>
-          <a:p>
-            <a:r>
-              <a:rPr sz="700" i="1">
-                <a:solidFill>
-                  <a:srgbClr val="0F172A"/>
-                </a:solidFill>
-              </a:rPr>
-              <a:t>I am building [describe your startup]. I am working on the The Problem slide of my pitch deck. Here is my current draft:
-Key Narrative: [paste yours]
-Proof Points: [paste yours]
-So What?: [paste yours]
-Help me sharpen this. Challenge weak claims, suggest stronger evidence, and rewrite the narrative to be more compelling. Keep it concise. Inves...</a:t>
-            </a:r>
-          </a:p>
-        </p:txBody>
-      </p:sp>
     </p:spTree>
   </p:cSld>
   <p:clrMapOvr>
@@ -6790,70 +6439,6 @@
           </a:p>
         </p:txBody>
       </p:sp>
-      <p:sp>
-        <p:nvSpPr>
-          <p:cNvPr id="4" name="TextBox 3"/>
-          <p:cNvSpPr txBox="1"/>
-          <p:nvPr/>
-        </p:nvSpPr>
-        <p:spPr>
-          <a:xfrm>
-            <a:off x="457200" y="5029200"/>
-            <a:ext cx="8229600" cy="1645920"/>
-          </a:xfrm>
-          <a:prstGeom prst="rect">
-            <a:avLst/>
-          </a:prstGeom>
-          <a:solidFill>
-            <a:srgbClr val="FFF7ED"/>
-          </a:solidFill>
-          <a:ln w="12700">
-            <a:solidFill>
-              <a:srgbClr val="EA580D"/>
-            </a:solidFill>
-          </a:ln>
-        </p:spPr>
-        <p:txBody>
-          <a:bodyPr wrap="square">
-            <a:spAutoFit/>
-          </a:bodyPr>
-          <a:lstStyle/>
-          <a:p>
-            <a:r>
-              <a:rPr sz="800" b="1">
-                <a:solidFill>
-                  <a:srgbClr val="EA580D"/>
-                </a:solidFill>
-              </a:rPr>
-              <a:t>AI COACH PROMPT</a:t>
-            </a:r>
-          </a:p>
-          <a:p>
-            <a:r>
-              <a:rPr sz="700">
-                <a:solidFill>
-                  <a:srgbClr val="64748B"/>
-                </a:solidFill>
-              </a:rPr>
-              <a:t>Copy the text below and paste it into ChatGPT, Claude, or any AI tool:</a:t>
-            </a:r>
-          </a:p>
-          <a:p>
-            <a:r>
-              <a:rPr sz="700" i="1">
-                <a:solidFill>
-                  <a:srgbClr val="0F172A"/>
-                </a:solidFill>
-              </a:rPr>
-              <a:t>I am building [describe your startup]. I am working on the The Solution slide of my pitch deck. Here is my current draft:
-Key Narrative: [paste yours]
-Proof Points: [paste yours]
-So What?: [paste yours]
-Help me sharpen this. Challenge weak claims, suggest stronger evidence, and rewrite the narrative to be more compelling. Keep it concise. Inve...</a:t>
-            </a:r>
-          </a:p>
-        </p:txBody>
-      </p:sp>
     </p:spTree>
   </p:cSld>
   <p:clrMapOvr>
@@ -7089,70 +6674,6 @@
           </a:p>
         </p:txBody>
       </p:sp>
-      <p:sp>
-        <p:nvSpPr>
-          <p:cNvPr id="4" name="TextBox 3"/>
-          <p:cNvSpPr txBox="1"/>
-          <p:nvPr/>
-        </p:nvSpPr>
-        <p:spPr>
-          <a:xfrm>
-            <a:off x="457200" y="5029200"/>
-            <a:ext cx="8229600" cy="1645920"/>
-          </a:xfrm>
-          <a:prstGeom prst="rect">
-            <a:avLst/>
-          </a:prstGeom>
-          <a:solidFill>
-            <a:srgbClr val="FFF7ED"/>
-          </a:solidFill>
-          <a:ln w="12700">
-            <a:solidFill>
-              <a:srgbClr val="EA580D"/>
-            </a:solidFill>
-          </a:ln>
-        </p:spPr>
-        <p:txBody>
-          <a:bodyPr wrap="square">
-            <a:spAutoFit/>
-          </a:bodyPr>
-          <a:lstStyle/>
-          <a:p>
-            <a:r>
-              <a:rPr sz="800" b="1">
-                <a:solidFill>
-                  <a:srgbClr val="EA580D"/>
-                </a:solidFill>
-              </a:rPr>
-              <a:t>AI COACH PROMPT</a:t>
-            </a:r>
-          </a:p>
-          <a:p>
-            <a:r>
-              <a:rPr sz="700">
-                <a:solidFill>
-                  <a:srgbClr val="64748B"/>
-                </a:solidFill>
-              </a:rPr>
-              <a:t>Copy the text below and paste it into ChatGPT, Claude, or any AI tool:</a:t>
-            </a:r>
-          </a:p>
-          <a:p>
-            <a:r>
-              <a:rPr sz="700" i="1">
-                <a:solidFill>
-                  <a:srgbClr val="0F172A"/>
-                </a:solidFill>
-              </a:rPr>
-              <a:t>I am building [describe your startup]. I am working on the The Market slide of my pitch deck. Here is my current draft:
-Key Narrative: [paste yours]
-Proof Points: [paste yours]
-So What?: [paste yours]
-Help me sharpen this. Challenge weak claims, suggest stronger evidence, and rewrite the narrative to be more compelling. Keep it concise. Invest...</a:t>
-            </a:r>
-          </a:p>
-        </p:txBody>
-      </p:sp>
     </p:spTree>
   </p:cSld>
   <p:clrMapOvr>
@@ -7388,70 +6909,6 @@
           </a:p>
         </p:txBody>
       </p:sp>
-      <p:sp>
-        <p:nvSpPr>
-          <p:cNvPr id="4" name="TextBox 3"/>
-          <p:cNvSpPr txBox="1"/>
-          <p:nvPr/>
-        </p:nvSpPr>
-        <p:spPr>
-          <a:xfrm>
-            <a:off x="457200" y="5029200"/>
-            <a:ext cx="8229600" cy="1645920"/>
-          </a:xfrm>
-          <a:prstGeom prst="rect">
-            <a:avLst/>
-          </a:prstGeom>
-          <a:solidFill>
-            <a:srgbClr val="FFF7ED"/>
-          </a:solidFill>
-          <a:ln w="12700">
-            <a:solidFill>
-              <a:srgbClr val="EA580D"/>
-            </a:solidFill>
-          </a:ln>
-        </p:spPr>
-        <p:txBody>
-          <a:bodyPr wrap="square">
-            <a:spAutoFit/>
-          </a:bodyPr>
-          <a:lstStyle/>
-          <a:p>
-            <a:r>
-              <a:rPr sz="800" b="1">
-                <a:solidFill>
-                  <a:srgbClr val="EA580D"/>
-                </a:solidFill>
-              </a:rPr>
-              <a:t>AI COACH PROMPT</a:t>
-            </a:r>
-          </a:p>
-          <a:p>
-            <a:r>
-              <a:rPr sz="700">
-                <a:solidFill>
-                  <a:srgbClr val="64748B"/>
-                </a:solidFill>
-              </a:rPr>
-              <a:t>Copy the text below and paste it into ChatGPT, Claude, or any AI tool:</a:t>
-            </a:r>
-          </a:p>
-          <a:p>
-            <a:r>
-              <a:rPr sz="700" i="1">
-                <a:solidFill>
-                  <a:srgbClr val="0F172A"/>
-                </a:solidFill>
-              </a:rPr>
-              <a:t>I am building [describe your startup]. I am working on the The Product slide of my pitch deck. Here is my current draft:
-Key Narrative: [paste yours]
-Proof Points: [paste yours]
-So What?: [paste yours]
-Help me sharpen this. Challenge weak claims, suggest stronger evidence, and rewrite the narrative to be more compelling. Keep it concise. Inves...</a:t>
-            </a:r>
-          </a:p>
-        </p:txBody>
-      </p:sp>
     </p:spTree>
   </p:cSld>
   <p:clrMapOvr>
@@ -7687,70 +7144,6 @@
           </a:p>
         </p:txBody>
       </p:sp>
-      <p:sp>
-        <p:nvSpPr>
-          <p:cNvPr id="4" name="TextBox 3"/>
-          <p:cNvSpPr txBox="1"/>
-          <p:nvPr/>
-        </p:nvSpPr>
-        <p:spPr>
-          <a:xfrm>
-            <a:off x="457200" y="5029200"/>
-            <a:ext cx="8229600" cy="1645920"/>
-          </a:xfrm>
-          <a:prstGeom prst="rect">
-            <a:avLst/>
-          </a:prstGeom>
-          <a:solidFill>
-            <a:srgbClr val="FFF7ED"/>
-          </a:solidFill>
-          <a:ln w="12700">
-            <a:solidFill>
-              <a:srgbClr val="EA580D"/>
-            </a:solidFill>
-          </a:ln>
-        </p:spPr>
-        <p:txBody>
-          <a:bodyPr wrap="square">
-            <a:spAutoFit/>
-          </a:bodyPr>
-          <a:lstStyle/>
-          <a:p>
-            <a:r>
-              <a:rPr sz="800" b="1">
-                <a:solidFill>
-                  <a:srgbClr val="EA580D"/>
-                </a:solidFill>
-              </a:rPr>
-              <a:t>AI COACH PROMPT</a:t>
-            </a:r>
-          </a:p>
-          <a:p>
-            <a:r>
-              <a:rPr sz="700">
-                <a:solidFill>
-                  <a:srgbClr val="64748B"/>
-                </a:solidFill>
-              </a:rPr>
-              <a:t>Copy the text below and paste it into ChatGPT, Claude, or any AI tool:</a:t>
-            </a:r>
-          </a:p>
-          <a:p>
-            <a:r>
-              <a:rPr sz="700" i="1">
-                <a:solidFill>
-                  <a:srgbClr val="0F172A"/>
-                </a:solidFill>
-              </a:rPr>
-              <a:t>I am building [describe your startup]. I am working on the Business Model slide of my pitch deck. Here is my current draft:
-Key Narrative: [paste yours]
-Proof Points: [paste yours]
-So What?: [paste yours]
-Help me sharpen this. Challenge weak claims, suggest stronger evidence, and rewrite the narrative to be more compelling. Keep it concise. In...</a:t>
-            </a:r>
-          </a:p>
-        </p:txBody>
-      </p:sp>
     </p:spTree>
   </p:cSld>
   <p:clrMapOvr>
@@ -7986,70 +7379,6 @@
           </a:p>
         </p:txBody>
       </p:sp>
-      <p:sp>
-        <p:nvSpPr>
-          <p:cNvPr id="4" name="TextBox 3"/>
-          <p:cNvSpPr txBox="1"/>
-          <p:nvPr/>
-        </p:nvSpPr>
-        <p:spPr>
-          <a:xfrm>
-            <a:off x="457200" y="5029200"/>
-            <a:ext cx="8229600" cy="1645920"/>
-          </a:xfrm>
-          <a:prstGeom prst="rect">
-            <a:avLst/>
-          </a:prstGeom>
-          <a:solidFill>
-            <a:srgbClr val="FFF7ED"/>
-          </a:solidFill>
-          <a:ln w="12700">
-            <a:solidFill>
-              <a:srgbClr val="EA580D"/>
-            </a:solidFill>
-          </a:ln>
-        </p:spPr>
-        <p:txBody>
-          <a:bodyPr wrap="square">
-            <a:spAutoFit/>
-          </a:bodyPr>
-          <a:lstStyle/>
-          <a:p>
-            <a:r>
-              <a:rPr sz="800" b="1">
-                <a:solidFill>
-                  <a:srgbClr val="EA580D"/>
-                </a:solidFill>
-              </a:rPr>
-              <a:t>AI COACH PROMPT</a:t>
-            </a:r>
-          </a:p>
-          <a:p>
-            <a:r>
-              <a:rPr sz="700">
-                <a:solidFill>
-                  <a:srgbClr val="64748B"/>
-                </a:solidFill>
-              </a:rPr>
-              <a:t>Copy the text below and paste it into ChatGPT, Claude, or any AI tool:</a:t>
-            </a:r>
-          </a:p>
-          <a:p>
-            <a:r>
-              <a:rPr sz="700" i="1">
-                <a:solidFill>
-                  <a:srgbClr val="0F172A"/>
-                </a:solidFill>
-              </a:rPr>
-              <a:t>I am building [describe your startup]. I am working on the Traction slide of my pitch deck. Here is my current draft:
-Key Narrative: [paste yours]
-Proof Points: [paste yours]
-So What?: [paste yours]
-Help me sharpen this. Challenge weak claims, suggest stronger evidence, and rewrite the narrative to be more compelling. Keep it concise. Investor...</a:t>
-            </a:r>
-          </a:p>
-        </p:txBody>
-      </p:sp>
     </p:spTree>
   </p:cSld>
   <p:clrMapOvr>
@@ -8281,70 +7610,6 @@
                 <a:latin typeface="Calibri"/>
               </a:rPr>
               <a:t>________________________________________</a:t>
-            </a:r>
-          </a:p>
-        </p:txBody>
-      </p:sp>
-      <p:sp>
-        <p:nvSpPr>
-          <p:cNvPr id="4" name="TextBox 3"/>
-          <p:cNvSpPr txBox="1"/>
-          <p:nvPr/>
-        </p:nvSpPr>
-        <p:spPr>
-          <a:xfrm>
-            <a:off x="457200" y="5029200"/>
-            <a:ext cx="8229600" cy="1645920"/>
-          </a:xfrm>
-          <a:prstGeom prst="rect">
-            <a:avLst/>
-          </a:prstGeom>
-          <a:solidFill>
-            <a:srgbClr val="FFF7ED"/>
-          </a:solidFill>
-          <a:ln w="12700">
-            <a:solidFill>
-              <a:srgbClr val="EA580D"/>
-            </a:solidFill>
-          </a:ln>
-        </p:spPr>
-        <p:txBody>
-          <a:bodyPr wrap="square">
-            <a:spAutoFit/>
-          </a:bodyPr>
-          <a:lstStyle/>
-          <a:p>
-            <a:r>
-              <a:rPr sz="800" b="1">
-                <a:solidFill>
-                  <a:srgbClr val="EA580D"/>
-                </a:solidFill>
-              </a:rPr>
-              <a:t>AI COACH PROMPT</a:t>
-            </a:r>
-          </a:p>
-          <a:p>
-            <a:r>
-              <a:rPr sz="700">
-                <a:solidFill>
-                  <a:srgbClr val="64748B"/>
-                </a:solidFill>
-              </a:rPr>
-              <a:t>Copy the text below and paste it into ChatGPT, Claude, or any AI tool:</a:t>
-            </a:r>
-          </a:p>
-          <a:p>
-            <a:r>
-              <a:rPr sz="700" i="1">
-                <a:solidFill>
-                  <a:srgbClr val="0F172A"/>
-                </a:solidFill>
-              </a:rPr>
-              <a:t>I am building [describe your startup]. I am working on the The Team slide of my pitch deck. Here is my current draft:
-Key Narrative: [paste yours]
-Proof Points: [paste yours]
-So What?: [paste yours]
-Help me sharpen this. Challenge weak claims, suggest stronger evidence, and rewrite the narrative to be more compelling. Keep it concise. Investor...</a:t>
             </a:r>
           </a:p>
         </p:txBody>

</xml_diff>